<commit_message>
assets: reframe Mobile-first slide from constraint to design
"Mobile-first by design" not "by constraint." Mobile-first isn't a
limitation PRISM works around \u2014 it's a deliberate design choice that
produces concrete strengths: file-based outputs, filename discipline,
operator hints, "What's next" all serve the real substrate of a human
moving artifacts between vendor chats.
</commit_message>
<xml_diff>
--- a/assets/PRISM_teaser.pptx
+++ b/assets/PRISM_teaser.pptx
@@ -7060,7 +7060,7 @@
                 <a:ea typeface="Calibri" pitchFamily="34" charset="-122"/>
                 <a:cs typeface="Calibri" pitchFamily="34" charset="-120"/>
               </a:rPr>
-              <a:t>MOBILE-FIRST BY CONSTRAINT</a:t>
+              <a:t>MOBILE-FIRST BY DESIGN</a:t>
             </a:r>
             <a:endParaRPr lang="en-US" sz="1200" dirty="0"/>
           </a:p>
@@ -7099,7 +7099,7 @@
                 <a:ea typeface="Georgia" pitchFamily="34" charset="-122"/>
                 <a:cs typeface="Georgia" pitchFamily="34" charset="-120"/>
               </a:rPr>
-              <a:t>The substrate dictates the architecture.</a:t>
+              <a:t>Designed around how you actually work.</a:t>
             </a:r>
             <a:endParaRPr lang="en-US" sz="3200" dirty="0"/>
           </a:p>
@@ -7138,7 +7138,7 @@
                 <a:ea typeface="Georgia" pitchFamily="34" charset="-122"/>
                 <a:cs typeface="Georgia" pitchFamily="34" charset="-120"/>
               </a:rPr>
-              <a:t>PRISM is shaped around how the operator actually works: a phone, a chat box, a markdown file. No plugins, no automation, no special tooling required.</a:t>
+              <a:t>The real substrate is a human moving artifacts between vendor chats, often on a phone. PRISM is built for that — file-based outputs, filename discipline, operator hints, and “What’s next” all serve it directly.</a:t>
             </a:r>
             <a:endParaRPr lang="en-US" sz="1400" dirty="0"/>
           </a:p>
@@ -7546,7 +7546,7 @@
                 <a:ea typeface="Georgia" pitchFamily="34" charset="-122"/>
                 <a:cs typeface="Georgia" pitchFamily="34" charset="-120"/>
               </a:rPr>
-              <a:t>Three-leg constraint (§1.3): Operator  ·  Substrate  ·  Methodology  —  mechanics that violate any leg don’t earn their place.</a:t>
+              <a:t>Three-leg design (§1.3): Operator  ·  Substrate  ·  Methodology  —  every mechanic earns its place by serving all three.</a:t>
             </a:r>
             <a:endParaRPr lang="en-US" sz="1300" dirty="0"/>
           </a:p>

</xml_diff>